<commit_message>
Update buyer persona to Thomas (groom) and add images to presentation
Co-authored-by: adnene1998 <82228138+adnene1998@users.noreply.github.com>
</commit_message>
<xml_diff>
--- a/Plan_Marketing_Plateforme_Gestion_Fetes.pptx
+++ b/Plan_Marketing_Plateforme_Gestion_Fetes.pptx
@@ -3178,7 +3178,7 @@
           <a:lstStyle/>
           <a:p>
             <a:r>
-              <a:t>Buyer Persona - Sarah, l'Organisatrice Particulière</a:t>
+              <a:t>Buyer Persona - Thomas, le Futur Marié</a:t>
             </a:r>
           </a:p>
         </p:txBody>
@@ -3200,16 +3200,40 @@
           <a:p/>
         </p:txBody>
       </p:sp>
-      <p:sp>
-        <p:nvSpPr>
-          <p:cNvPr id="4" name="TextBox 3"/>
+      <p:pic>
+        <p:nvPicPr>
+          <p:cNvPr id="4" name="Picture 3" descr="persona_thomas.png"/>
+          <p:cNvPicPr>
+            <a:picLocks noChangeAspect="1"/>
+          </p:cNvPicPr>
+          <p:nvPr/>
+        </p:nvPicPr>
+        <p:blipFill>
+          <a:blip r:embed="rId2"/>
+          <a:stretch>
+            <a:fillRect/>
+          </a:stretch>
+        </p:blipFill>
+        <p:spPr>
+          <a:xfrm>
+            <a:off x="457200" y="1828800"/>
+            <a:ext cx="2560320" cy="2560320"/>
+          </a:xfrm>
+          <a:prstGeom prst="rect">
+            <a:avLst/>
+          </a:prstGeom>
+        </p:spPr>
+      </p:pic>
+      <p:sp>
+        <p:nvSpPr>
+          <p:cNvPr id="5" name="TextBox 4"/>
           <p:cNvSpPr txBox="1"/>
           <p:nvPr/>
         </p:nvSpPr>
         <p:spPr>
           <a:xfrm>
-            <a:off x="914400" y="1645920"/>
-            <a:ext cx="7315200" cy="4572000"/>
+            <a:off x="3200400" y="1645920"/>
+            <a:ext cx="5486400" cy="4572000"/>
           </a:xfrm>
           <a:prstGeom prst="rect">
             <a:avLst/>
@@ -3234,15 +3258,15 @@
               <a:defRPr sz="1800"/>
             </a:pPr>
             <a:r>
-              <a:t>  - 32 ans, mariée, 1 enfant</a:t>
-            </a:r>
-          </a:p>
-          <a:p>
-            <a:pPr>
-              <a:defRPr sz="1800"/>
-            </a:pPr>
-            <a:r>
-              <a:t>  - Cadre dans une entreprise de marketing</a:t>
+              <a:t>  - 30 ans, fiancé, va se marier dans 6 mois</a:t>
+            </a:r>
+          </a:p>
+          <a:p>
+            <a:pPr>
+              <a:defRPr sz="1800"/>
+            </a:pPr>
+            <a:r>
+              <a:t>  - Ingénieur dans une entreprise tech</a:t>
             </a:r>
           </a:p>
           <a:p>
@@ -3266,23 +3290,31 @@
               <a:defRPr sz="1800"/>
             </a:pPr>
             <a:r>
-              <a:t>  - Organiser le mariage de sa sœur</a:t>
-            </a:r>
-          </a:p>
-          <a:p>
-            <a:pPr>
-              <a:defRPr sz="1800"/>
-            </a:pPr>
-            <a:r>
-              <a:t>  - Créer un événement mémorable dans son budget</a:t>
-            </a:r>
-          </a:p>
-          <a:p>
-            <a:pPr>
-              <a:defRPr sz="1800"/>
-            </a:pPr>
-            <a:r>
-              <a:t>  - Gagner du temps dans l'organisation</a:t>
+              <a:t>  - Organiser son propre mariage</a:t>
+            </a:r>
+          </a:p>
+          <a:p>
+            <a:pPr>
+              <a:defRPr sz="1800"/>
+            </a:pPr>
+            <a:r>
+              <a:t>  - Créer un événement inoubliable pour lui et sa fiancée</a:t>
+            </a:r>
+          </a:p>
+          <a:p>
+            <a:pPr>
+              <a:defRPr sz="1800"/>
+            </a:pPr>
+            <a:r>
+              <a:t>  - Optimiser le budget et gagner du temps</a:t>
+            </a:r>
+          </a:p>
+          <a:p>
+            <a:pPr>
+              <a:defRPr sz="1800"/>
+            </a:pPr>
+            <a:r>
+              <a:t>  - Impressionner famille et amis</a:t>
             </a:r>
           </a:p>
           <a:p>
@@ -3298,6 +3330,14 @@
               <a:defRPr sz="1800"/>
             </a:pPr>
             <a:r>
+              <a:t>  - Première expérience d'organisation de mariage</a:t>
+            </a:r>
+          </a:p>
+          <a:p>
+            <a:pPr>
+              <a:defRPr sz="1800"/>
+            </a:pPr>
+            <a:r>
               <a:t>  - Manque de temps avec son travail</a:t>
             </a:r>
           </a:p>
@@ -3314,7 +3354,7 @@
               <a:defRPr sz="1800"/>
             </a:pPr>
             <a:r>
-              <a:t>  - Stress de la gestion du budget</a:t>
+              <a:t>  - Stress de la gestion du budget et des choix</a:t>
             </a:r>
           </a:p>
           <a:p>
@@ -3330,23 +3370,23 @@
               <a:defRPr sz="1800"/>
             </a:pPr>
             <a:r>
-              <a:t>  - Recherche en ligne de solutions</a:t>
-            </a:r>
-          </a:p>
-          <a:p>
-            <a:pPr>
-              <a:defRPr sz="1800"/>
-            </a:pPr>
-            <a:r>
-              <a:t>  - Active sur les réseaux sociaux</a:t>
-            </a:r>
-          </a:p>
-          <a:p>
-            <a:pPr>
-              <a:defRPr sz="1800"/>
-            </a:pPr>
-            <a:r>
-              <a:t>  - Lit les avis avant de choisir</a:t>
+              <a:t>  - Recherche en ligne de solutions et comparaisons</a:t>
+            </a:r>
+          </a:p>
+          <a:p>
+            <a:pPr>
+              <a:defRPr sz="1800"/>
+            </a:pPr>
+            <a:r>
+              <a:t>  - Consulte forums et avis clients</a:t>
+            </a:r>
+          </a:p>
+          <a:p>
+            <a:pPr>
+              <a:defRPr sz="1800"/>
+            </a:pPr>
+            <a:r>
+              <a:t>  - Valorise l'efficacité et la technologie</a:t>
             </a:r>
           </a:p>
         </p:txBody>
@@ -3407,16 +3447,40 @@
           <a:p/>
         </p:txBody>
       </p:sp>
-      <p:sp>
-        <p:nvSpPr>
-          <p:cNvPr id="4" name="TextBox 3"/>
+      <p:pic>
+        <p:nvPicPr>
+          <p:cNvPr id="4" name="Picture 3" descr="persona_marc.png"/>
+          <p:cNvPicPr>
+            <a:picLocks noChangeAspect="1"/>
+          </p:cNvPicPr>
+          <p:nvPr/>
+        </p:nvPicPr>
+        <p:blipFill>
+          <a:blip r:embed="rId2"/>
+          <a:stretch>
+            <a:fillRect/>
+          </a:stretch>
+        </p:blipFill>
+        <p:spPr>
+          <a:xfrm>
+            <a:off x="457200" y="1828800"/>
+            <a:ext cx="2560320" cy="2560320"/>
+          </a:xfrm>
+          <a:prstGeom prst="rect">
+            <a:avLst/>
+          </a:prstGeom>
+        </p:spPr>
+      </p:pic>
+      <p:sp>
+        <p:nvSpPr>
+          <p:cNvPr id="5" name="TextBox 4"/>
           <p:cNvSpPr txBox="1"/>
           <p:nvPr/>
         </p:nvSpPr>
         <p:spPr>
           <a:xfrm>
-            <a:off x="914400" y="1645920"/>
-            <a:ext cx="7315200" cy="4572000"/>
+            <a:off x="3200400" y="1645920"/>
+            <a:ext cx="5486400" cy="4572000"/>
           </a:xfrm>
           <a:prstGeom prst="rect">
             <a:avLst/>
@@ -3614,16 +3678,40 @@
           <a:p/>
         </p:txBody>
       </p:sp>
-      <p:sp>
-        <p:nvSpPr>
-          <p:cNvPr id="4" name="TextBox 3"/>
+      <p:pic>
+        <p:nvPicPr>
+          <p:cNvPr id="4" name="Picture 3" descr="customer_journey.png"/>
+          <p:cNvPicPr>
+            <a:picLocks noChangeAspect="1"/>
+          </p:cNvPicPr>
+          <p:nvPr/>
+        </p:nvPicPr>
+        <p:blipFill>
+          <a:blip r:embed="rId2"/>
+          <a:stretch>
+            <a:fillRect/>
+          </a:stretch>
+        </p:blipFill>
+        <p:spPr>
+          <a:xfrm>
+            <a:off x="2743200" y="1371600"/>
+            <a:ext cx="3657600" cy="1371600"/>
+          </a:xfrm>
+          <a:prstGeom prst="rect">
+            <a:avLst/>
+          </a:prstGeom>
+        </p:spPr>
+      </p:pic>
+      <p:sp>
+        <p:nvSpPr>
+          <p:cNvPr id="5" name="TextBox 4"/>
           <p:cNvSpPr txBox="1"/>
           <p:nvPr/>
         </p:nvSpPr>
         <p:spPr>
           <a:xfrm>
-            <a:off x="914400" y="1645920"/>
-            <a:ext cx="7315200" cy="4572000"/>
+            <a:off x="457200" y="2926080"/>
+            <a:ext cx="8229600" cy="3474720"/>
           </a:xfrm>
           <a:prstGeom prst="rect">
             <a:avLst/>
@@ -4349,16 +4437,40 @@
           <a:p/>
         </p:txBody>
       </p:sp>
-      <p:sp>
-        <p:nvSpPr>
-          <p:cNvPr id="4" name="TextBox 3"/>
+      <p:pic>
+        <p:nvPicPr>
+          <p:cNvPr id="4" name="Picture 3" descr="platform.png"/>
+          <p:cNvPicPr>
+            <a:picLocks noChangeAspect="1"/>
+          </p:cNvPicPr>
+          <p:nvPr/>
+        </p:nvPicPr>
+        <p:blipFill>
+          <a:blip r:embed="rId2"/>
+          <a:stretch>
+            <a:fillRect/>
+          </a:stretch>
+        </p:blipFill>
+        <p:spPr>
+          <a:xfrm>
+            <a:off x="5943600" y="1828800"/>
+            <a:ext cx="2743200" cy="2057400"/>
+          </a:xfrm>
+          <a:prstGeom prst="rect">
+            <a:avLst/>
+          </a:prstGeom>
+        </p:spPr>
+      </p:pic>
+      <p:sp>
+        <p:nvSpPr>
+          <p:cNvPr id="5" name="TextBox 4"/>
           <p:cNvSpPr txBox="1"/>
           <p:nvPr/>
         </p:nvSpPr>
         <p:spPr>
           <a:xfrm>
-            <a:off x="914400" y="1828800"/>
-            <a:ext cx="7315200" cy="3657600"/>
+            <a:off x="457200" y="1828800"/>
+            <a:ext cx="5029200" cy="3657600"/>
           </a:xfrm>
           <a:prstGeom prst="rect">
             <a:avLst/>
@@ -4460,16 +4572,40 @@
           <a:p/>
         </p:txBody>
       </p:sp>
-      <p:sp>
-        <p:nvSpPr>
-          <p:cNvPr id="4" name="TextBox 3"/>
+      <p:pic>
+        <p:nvPicPr>
+          <p:cNvPr id="4" name="Picture 3" descr="segmentation.png"/>
+          <p:cNvPicPr>
+            <a:picLocks noChangeAspect="1"/>
+          </p:cNvPicPr>
+          <p:nvPr/>
+        </p:nvPicPr>
+        <p:blipFill>
+          <a:blip r:embed="rId2"/>
+          <a:stretch>
+            <a:fillRect/>
+          </a:stretch>
+        </p:blipFill>
+        <p:spPr>
+          <a:xfrm>
+            <a:off x="5943600" y="2286000"/>
+            <a:ext cx="2743200" cy="2057400"/>
+          </a:xfrm>
+          <a:prstGeom prst="rect">
+            <a:avLst/>
+          </a:prstGeom>
+        </p:spPr>
+      </p:pic>
+      <p:sp>
+        <p:nvSpPr>
+          <p:cNvPr id="5" name="TextBox 4"/>
           <p:cNvSpPr txBox="1"/>
           <p:nvPr/>
         </p:nvSpPr>
         <p:spPr>
           <a:xfrm>
-            <a:off x="914400" y="1828800"/>
-            <a:ext cx="7315200" cy="4114800"/>
+            <a:off x="457200" y="1828800"/>
+            <a:ext cx="5029200" cy="4114800"/>
           </a:xfrm>
           <a:prstGeom prst="rect">
             <a:avLst/>
@@ -4961,16 +5097,40 @@
           <a:p/>
         </p:txBody>
       </p:sp>
-      <p:sp>
-        <p:nvSpPr>
-          <p:cNvPr id="4" name="TextBox 3"/>
+      <p:pic>
+        <p:nvPicPr>
+          <p:cNvPr id="4" name="Picture 3" descr="marketing_mix.png"/>
+          <p:cNvPicPr>
+            <a:picLocks noChangeAspect="1"/>
+          </p:cNvPicPr>
+          <p:nvPr/>
+        </p:nvPicPr>
+        <p:blipFill>
+          <a:blip r:embed="rId2"/>
+          <a:stretch>
+            <a:fillRect/>
+          </a:stretch>
+        </p:blipFill>
+        <p:spPr>
+          <a:xfrm>
+            <a:off x="5943600" y="2286000"/>
+            <a:ext cx="2743200" cy="2057400"/>
+          </a:xfrm>
+          <a:prstGeom prst="rect">
+            <a:avLst/>
+          </a:prstGeom>
+        </p:spPr>
+      </p:pic>
+      <p:sp>
+        <p:nvSpPr>
+          <p:cNvPr id="5" name="TextBox 4"/>
           <p:cNvSpPr txBox="1"/>
           <p:nvPr/>
         </p:nvSpPr>
         <p:spPr>
           <a:xfrm>
-            <a:off x="914400" y="1828800"/>
-            <a:ext cx="7315200" cy="4114800"/>
+            <a:off x="457200" y="1828800"/>
+            <a:ext cx="5029200" cy="4114800"/>
           </a:xfrm>
           <a:prstGeom prst="rect">
             <a:avLst/>

</xml_diff>

<commit_message>
Update segmentation to hierarchical approach (gender-based with subgroups)
Co-authored-by: adnene1998 <82228138+adnene1998@users.noreply.github.com>
</commit_message>
<xml_diff>
--- a/Plan_Marketing_Plateforme_Gestion_Fetes.pptx
+++ b/Plan_Marketing_Plateforme_Gestion_Fetes.pptx
@@ -4604,8 +4604,8 @@
         </p:nvSpPr>
         <p:spPr>
           <a:xfrm>
-            <a:off x="457200" y="1828800"/>
-            <a:ext cx="5029200" cy="4114800"/>
+            <a:off x="457200" y="1645920"/>
+            <a:ext cx="5029200" cy="4572000"/>
           </a:xfrm>
           <a:prstGeom prst="rect">
             <a:avLst/>
@@ -4622,87 +4622,131 @@
               <a:defRPr sz="1800"/>
             </a:pPr>
             <a:r>
-              <a:t>Segment 1: Particuliers (mariages, anniversaires, fêtes familiales)</a:t>
-            </a:r>
-          </a:p>
-          <a:p>
-            <a:pPr>
-              <a:defRPr sz="1800"/>
-            </a:pPr>
-            <a:r>
-              <a:t>  - Âge: 25-55 ans</a:t>
-            </a:r>
-          </a:p>
-          <a:p>
-            <a:pPr>
-              <a:defRPr sz="1800"/>
-            </a:pPr>
-            <a:r>
-              <a:t>  - Revenus moyens à élevés</a:t>
-            </a:r>
-          </a:p>
-          <a:p>
-            <a:pPr>
-              <a:defRPr sz="1800"/>
-            </a:pPr>
-            <a:r>
-              <a:t>  - Recherchent simplicité et qualité</a:t>
-            </a:r>
-          </a:p>
-          <a:p>
-            <a:pPr>
-              <a:defRPr sz="1800"/>
-            </a:pPr>
-            <a:r>
-              <a:t>Segment 2: Professionnels de l'événementiel</a:t>
-            </a:r>
-          </a:p>
-          <a:p>
-            <a:pPr>
-              <a:defRPr sz="1800"/>
-            </a:pPr>
-            <a:r>
-              <a:t>  - Organisateurs d'événements</a:t>
-            </a:r>
-          </a:p>
-          <a:p>
-            <a:pPr>
-              <a:defRPr sz="1800"/>
-            </a:pPr>
-            <a:r>
-              <a:t>  - Entreprises (événements corporatifs)</a:t>
-            </a:r>
-          </a:p>
-          <a:p>
-            <a:pPr>
-              <a:defRPr sz="1800"/>
-            </a:pPr>
-            <a:r>
-              <a:t>  - Besoin d'outils professionnels et de gestion</a:t>
-            </a:r>
-          </a:p>
-          <a:p>
-            <a:pPr>
-              <a:defRPr sz="1800"/>
-            </a:pPr>
-            <a:r>
-              <a:t>Segment 3: Petites entreprises et associations</a:t>
-            </a:r>
-          </a:p>
-          <a:p>
-            <a:pPr>
-              <a:defRPr sz="1800"/>
-            </a:pPr>
-            <a:r>
-              <a:t>  - Budget limité</a:t>
-            </a:r>
-          </a:p>
-          <a:p>
-            <a:pPr>
-              <a:defRPr sz="1800"/>
-            </a:pPr>
-            <a:r>
-              <a:t>  - Événements récurrents</a:t>
+              <a:t>Processus de segmentation hiérarchique:</a:t>
+            </a:r>
+          </a:p>
+          <a:p>
+            <a:pPr>
+              <a:defRPr sz="1800"/>
+            </a:pPr>
+          </a:p>
+          <a:p>
+            <a:pPr>
+              <a:defRPr sz="1800"/>
+            </a:pPr>
+            <a:r>
+              <a:t>1. Segmentation primaire par GENRE:</a:t>
+            </a:r>
+          </a:p>
+          <a:p>
+            <a:pPr>
+              <a:defRPr sz="1800"/>
+            </a:pPr>
+            <a:r>
+              <a:t>  → Hommes | Femmes</a:t>
+            </a:r>
+          </a:p>
+          <a:p>
+            <a:pPr>
+              <a:defRPr sz="1800"/>
+            </a:pPr>
+          </a:p>
+          <a:p>
+            <a:pPr>
+              <a:defRPr sz="1800"/>
+            </a:pPr>
+            <a:r>
+              <a:t>2. Segmentation HOMMES:</a:t>
+            </a:r>
+          </a:p>
+          <a:p>
+            <a:pPr>
+              <a:defRPr sz="1800"/>
+            </a:pPr>
+            <a:r>
+              <a:t>  • Jeunes mariés (25-35 ans) - organisent leur mariage</a:t>
+            </a:r>
+          </a:p>
+          <a:p>
+            <a:pPr>
+              <a:defRPr sz="1800"/>
+            </a:pPr>
+            <a:r>
+              <a:t>  • Professionnels événementiels (30-50 ans)</a:t>
+            </a:r>
+          </a:p>
+          <a:p>
+            <a:pPr>
+              <a:defRPr sz="1800"/>
+            </a:pPr>
+            <a:r>
+              <a:t>  • Entrepreneurs/Entreprises - événements corporatifs</a:t>
+            </a:r>
+          </a:p>
+          <a:p>
+            <a:pPr>
+              <a:defRPr sz="1800"/>
+            </a:pPr>
+          </a:p>
+          <a:p>
+            <a:pPr>
+              <a:defRPr sz="1800"/>
+            </a:pPr>
+            <a:r>
+              <a:t>3. Segmentation FEMMES:</a:t>
+            </a:r>
+          </a:p>
+          <a:p>
+            <a:pPr>
+              <a:defRPr sz="1800"/>
+            </a:pPr>
+            <a:r>
+              <a:t>  • Jeunes mariées (25-35 ans) - organisent leur mariage</a:t>
+            </a:r>
+          </a:p>
+          <a:p>
+            <a:pPr>
+              <a:defRPr sz="1800"/>
+            </a:pPr>
+            <a:r>
+              <a:t>  • Organisatrices familiales (30-50 ans) - fêtes familiales</a:t>
+            </a:r>
+          </a:p>
+          <a:p>
+            <a:pPr>
+              <a:defRPr sz="1800"/>
+            </a:pPr>
+            <a:r>
+              <a:t>  • Professionnelles événementielles (25-55 ans)</a:t>
+            </a:r>
+          </a:p>
+          <a:p>
+            <a:pPr>
+              <a:defRPr sz="1800"/>
+            </a:pPr>
+          </a:p>
+          <a:p>
+            <a:pPr>
+              <a:defRPr sz="1800"/>
+            </a:pPr>
+            <a:r>
+              <a:t>4. Segmentation secondaire (transversale):</a:t>
+            </a:r>
+          </a:p>
+          <a:p>
+            <a:pPr>
+              <a:defRPr sz="1800"/>
+            </a:pPr>
+            <a:r>
+              <a:t>  • Par budget: Économique | Standard | Premium</a:t>
+            </a:r>
+          </a:p>
+          <a:p>
+            <a:pPr>
+              <a:defRPr sz="1800"/>
+            </a:pPr>
+            <a:r>
+              <a:t>  • Par type d'événement: Personnel | Professionnel</a:t>
             </a:r>
           </a:p>
         </p:txBody>

</xml_diff>